<commit_message>
Quita octubre 2026 del gráfico de integración
El gráfico termina en septiembre 2026; etiquetas finales en ese mes y
etiqueta de SQ bajo el punto para que no se pise con Global.

Co-Authored-By: Claude Opus 5.5 <noreply@anthropic.com>
Claude-Session: https://claude.ai/code/session_01UVYcGvnrywmVQkiA3sTncu
</commit_message>
<xml_diff>
--- a/presentaciones/Planificacion_Packaging_CL.pptx
+++ b/presentaciones/Planificacion_Packaging_CL.pptx
@@ -186,7 +186,7 @@
           </c:marker>
           <c:dLbls>
             <c:dLbl>
-              <c:idx val="21"/>
+              <c:idx val="20"/>
               <c:tx>
                 <c:rich>
                   <a:bodyPr/>
@@ -229,9 +229,9 @@
           </c:dLbls>
           <c:cat>
             <c:strRef>
-              <c:f>Sheet1!$A$2:$A$23</c:f>
+              <c:f>Sheet1!$A$2:$A$22</c:f>
               <c:strCache>
-                <c:ptCount val="22"/>
+                <c:ptCount val="21"/>
                 <c:pt idx="0">
                   <c:v>Ene 25</c:v>
                 </c:pt>
@@ -295,18 +295,15 @@
                 <c:pt idx="20">
                   <c:v>Sep 26</c:v>
                 </c:pt>
-                <c:pt idx="21">
-                  <c:v>Oct 26</c:v>
-                </c:pt>
               </c:strCache>
             </c:strRef>
           </c:cat>
           <c:val>
             <c:numRef>
-              <c:f>Sheet1!$B$2:$B$23</c:f>
+              <c:f>Sheet1!$B$2:$B$22</c:f>
               <c:numCache>
                 <c:formatCode>0%</c:formatCode>
-                <c:ptCount val="22"/>
+                <c:ptCount val="21"/>
                 <c:pt idx="0">
                   <c:v>0.61</c:v>
                 </c:pt>
@@ -370,9 +367,6 @@
                 <c:pt idx="20">
                   <c:v>0.86</c:v>
                 </c:pt>
-                <c:pt idx="21">
-                  <c:v>0.86</c:v>
-                </c:pt>
               </c:numCache>
             </c:numRef>
           </c:val>
@@ -415,14 +409,14 @@
           </c:marker>
           <c:dLbls>
             <c:dLbl>
-              <c:idx val="21"/>
+              <c:idx val="20"/>
               <c:tx>
                 <c:rich>
                   <a:bodyPr/>
                   <a:lstStyle/>
                   <a:p>
                     <a:r>
-                      <a:t>100%</a:t>
+                      <a:t>96%</a:t>
                     </a:r>
                   </a:p>
                 </c:rich>
@@ -458,9 +452,9 @@
           </c:dLbls>
           <c:cat>
             <c:strRef>
-              <c:f>Sheet1!$A$2:$A$23</c:f>
+              <c:f>Sheet1!$A$2:$A$22</c:f>
               <c:strCache>
-                <c:ptCount val="22"/>
+                <c:ptCount val="21"/>
                 <c:pt idx="0">
                   <c:v>Ene 25</c:v>
                 </c:pt>
@@ -524,18 +518,15 @@
                 <c:pt idx="20">
                   <c:v>Sep 26</c:v>
                 </c:pt>
-                <c:pt idx="21">
-                  <c:v>Oct 26</c:v>
-                </c:pt>
               </c:strCache>
             </c:strRef>
           </c:cat>
           <c:val>
             <c:numRef>
-              <c:f>Sheet1!$C$2:$C$23</c:f>
+              <c:f>Sheet1!$C$2:$C$22</c:f>
               <c:numCache>
                 <c:formatCode>0%</c:formatCode>
-                <c:ptCount val="22"/>
+                <c:ptCount val="21"/>
                 <c:pt idx="0">
                   <c:v>0.76</c:v>
                 </c:pt>
@@ -599,9 +590,6 @@
                 <c:pt idx="20">
                   <c:v>0.96</c:v>
                 </c:pt>
-                <c:pt idx="21">
-                  <c:v>1.0</c:v>
-                </c:pt>
               </c:numCache>
             </c:numRef>
           </c:val>
@@ -644,14 +632,14 @@
           </c:marker>
           <c:dLbls>
             <c:dLbl>
-              <c:idx val="21"/>
+              <c:idx val="20"/>
               <c:tx>
                 <c:rich>
                   <a:bodyPr/>
                   <a:lstStyle/>
                   <a:p>
                     <a:r>
-                      <a:t>78%</a:t>
+                      <a:t>82%</a:t>
                     </a:r>
                   </a:p>
                 </c:rich>
@@ -669,7 +657,7 @@
                   </a:pPr>
                 </a:p>
               </c:txPr>
-              <c:dLblPos val="r"/>
+              <c:dLblPos val="b"/>
               <c:showLegendKey val="0"/>
               <c:showVal val="1"/>
               <c:showCatName val="0"/>
@@ -687,9 +675,9 @@
           </c:dLbls>
           <c:cat>
             <c:strRef>
-              <c:f>Sheet1!$A$2:$A$23</c:f>
+              <c:f>Sheet1!$A$2:$A$22</c:f>
               <c:strCache>
-                <c:ptCount val="22"/>
+                <c:ptCount val="21"/>
                 <c:pt idx="0">
                   <c:v>Ene 25</c:v>
                 </c:pt>
@@ -753,18 +741,15 @@
                 <c:pt idx="20">
                   <c:v>Sep 26</c:v>
                 </c:pt>
-                <c:pt idx="21">
-                  <c:v>Oct 26</c:v>
-                </c:pt>
               </c:strCache>
             </c:strRef>
           </c:cat>
           <c:val>
             <c:numRef>
-              <c:f>Sheet1!$D$2:$D$23</c:f>
+              <c:f>Sheet1!$D$2:$D$22</c:f>
               <c:numCache>
                 <c:formatCode>0%</c:formatCode>
-                <c:ptCount val="22"/>
+                <c:ptCount val="21"/>
                 <c:pt idx="0">
                   <c:v>0.51</c:v>
                 </c:pt>
@@ -828,9 +813,6 @@
                 <c:pt idx="20">
                   <c:v>0.82</c:v>
                 </c:pt>
-                <c:pt idx="21">
-                  <c:v>0.78</c:v>
-                </c:pt>
               </c:numCache>
             </c:numRef>
           </c:val>
@@ -863,7 +845,7 @@
         <c:auto val="1"/>
         <c:lblAlgn val="ctr"/>
         <c:lblOffset val="100"/>
-        <c:tickLblSkip val="3"/>
+        <c:tickLblSkip val="2"/>
         <c:noMultiLvlLbl val="0"/>
       </c:catAx>
       <c:valAx>

</xml_diff>